<commit_message>
slide: ML Pipelines with Kedro and Prefect
</commit_message>
<xml_diff>
--- a/slides/5. ML Pipelines/ML Pipelines with Kedro and Prefect.pptx
+++ b/slides/5. ML Pipelines/ML Pipelines with Kedro and Prefect.pptx
@@ -5,7 +5,7 @@
     <p:sldMasterId id="2147483674" r:id="rId4"/>
   </p:sldMasterIdLst>
   <p:notesMasterIdLst>
-    <p:notesMasterId r:id="rId19"/>
+    <p:notesMasterId r:id="rId20"/>
   </p:notesMasterIdLst>
   <p:sldIdLst>
     <p:sldId id="256" r:id="rId5"/>
@@ -22,6 +22,7 @@
     <p:sldId id="1852" r:id="rId16"/>
     <p:sldId id="1853" r:id="rId17"/>
     <p:sldId id="1850" r:id="rId18"/>
+    <p:sldId id="1855" r:id="rId19"/>
   </p:sldIdLst>
   <p:sldSz cx="9144000" cy="5143500" type="screen16x9"/>
   <p:notesSz cx="6858000" cy="9144000"/>
@@ -4281,6 +4282,66 @@
     <p:extLst>
       <p:ext uri="{BB962C8B-B14F-4D97-AF65-F5344CB8AC3E}">
         <p14:creationId xmlns:p14="http://schemas.microsoft.com/office/powerpoint/2010/main" val="3294400399"/>
+      </p:ext>
+    </p:extLst>
+  </p:cSld>
+  <p:clrMapOvr>
+    <a:masterClrMapping/>
+  </p:clrMapOvr>
+</p:sld>
+</file>
+
+<file path=ppt/slides/slide15.xml><?xml version="1.0" encoding="utf-8"?>
+<p:sld xmlns:a="http://schemas.openxmlformats.org/drawingml/2006/main" xmlns:r="http://schemas.openxmlformats.org/officeDocument/2006/relationships" xmlns:p="http://schemas.openxmlformats.org/presentationml/2006/main">
+  <p:cSld>
+    <p:spTree>
+      <p:nvGrpSpPr>
+        <p:cNvPr id="1" name=""/>
+        <p:cNvGrpSpPr/>
+        <p:nvPr/>
+      </p:nvGrpSpPr>
+      <p:grpSpPr>
+        <a:xfrm>
+          <a:off x="0" y="0"/>
+          <a:ext cx="0" cy="0"/>
+          <a:chOff x="0" y="0"/>
+          <a:chExt cx="0" cy="0"/>
+        </a:xfrm>
+      </p:grpSpPr>
+      <p:pic>
+        <p:nvPicPr>
+          <p:cNvPr id="4" name="Obraz 3">
+            <a:extLst>
+              <a:ext uri="{FF2B5EF4-FFF2-40B4-BE49-F238E27FC236}">
+                <a16:creationId xmlns:a16="http://schemas.microsoft.com/office/drawing/2014/main" id="{3AD66B5E-3908-3D97-5F2D-80610C83B389}"/>
+              </a:ext>
+            </a:extLst>
+          </p:cNvPr>
+          <p:cNvPicPr>
+            <a:picLocks noChangeAspect="1"/>
+          </p:cNvPicPr>
+          <p:nvPr/>
+        </p:nvPicPr>
+        <p:blipFill>
+          <a:blip r:embed="rId2"/>
+          <a:stretch>
+            <a:fillRect/>
+          </a:stretch>
+        </p:blipFill>
+        <p:spPr>
+          <a:xfrm>
+            <a:off x="685800" y="368413"/>
+            <a:ext cx="7772400" cy="4406673"/>
+          </a:xfrm>
+          <a:prstGeom prst="rect">
+            <a:avLst/>
+          </a:prstGeom>
+        </p:spPr>
+      </p:pic>
+    </p:spTree>
+    <p:extLst>
+      <p:ext uri="{BB962C8B-B14F-4D97-AF65-F5344CB8AC3E}">
+        <p14:creationId xmlns:p14="http://schemas.microsoft.com/office/powerpoint/2010/main" val="2261707233"/>
       </p:ext>
     </p:extLst>
   </p:cSld>

</xml_diff>